<commit_message>
Revise poster and abstract wording; put poster and abstract first in README
Poster: brown-out terminology, consumption wording, battery named without
datasheet phrasing, 30-minute result stated without near-tie values, single
Azure keepalive limit of about 1,177 s with the 250 ms pacing explained,
exact 4,000 samples per second, Future Work spacing fixed. Abstract:
restructured to one paragraph with no semicolons. README: poster image and
full abstract now lead; Related records section added with the booklet DOI
placeholder.
</commit_message>
<xml_diff>
--- a/poster/FloodNet_UGSRP_Poster_Final.pptx
+++ b/poster/FloodNet_UGSRP_Poster_Final.pptx
@@ -11118,7 +11118,19 @@
               <a:rPr lang="en-US" sz="3467" b="0" dirty="0">
                 <a:latin typeface="Arial"/>
               </a:rPr>
-              <a:t>FloodNet is a street-level flood monitoring network with 450 sensors across New York City’s five boroughs. Each solar-powered unit measures water level every minute with an ultrasonic sensor and reports over cellular at a remotely settable interval (default 1 minute). In winter, shorter days and building shading cut solar harvest below what a shaded sensor spends: batteries drain over weeks and sensors go silent. To measure each reporting rate’s real cost, a sensor’s current draw was recorded with a Qoitech Otii Arc power analyzer at 1-, 15-, and 30-minute intervals. Slowing reporting from 1 to 15 minutes cut average draw by 41%, stretching a full charge from 49 to 84 days with no solar input. Slowing to 30 minutes saved nothing more: a 900-second MQTT keepalive wakes the modem mid-interval regardless. Fifteen-minute reporting therefore delivers the most live data at the lowest measured power. A server-side policy is proposed: 15-minute reporting below a battery voltage threshold, with 1-minute reporting restored when storms threaten.</a:t>
+              <a:t>FloodNet is a street-level flood monitoring network with 450 sensors across New York City’s five boroughs. Each solar-powered unit measures water level every minute with an ultrasonic sensor and reports over cellular at a remotely settable interval (default 1 minute). In winter, shorter days and building shading cut solar </a:t>
+            </a:r>
+            <a:r>
+              <a:rPr lang="en-US" sz="3467" b="0">
+                <a:latin typeface="Arial"/>
+              </a:rPr>
+              <a:t>harvest below what a shaded sensor consumes: batteries drain over weeks and sensors brown out. </a:t>
+            </a:r>
+            <a:r>
+              <a:rPr lang="en-US" sz="3467" b="0" dirty="0">
+                <a:latin typeface="Arial"/>
+              </a:rPr>
+              <a:t>To measure each reporting rate’s real cost, a sensor’s current draw was recorded with a Qoitech Otii Arc power analyzer at 1-, 15-, and 30-minute intervals. Slowing reporting from 1 to 15 minutes cut average draw by 41%, stretching a full charge from 49 to 84 days with no solar input. Slowing to 30 minutes saved nothing more: a 900-second MQTT keepalive wakes the modem mid-interval regardless. Fifteen-minute reporting therefore delivers the most live data at the lowest measured power. A server-side policy is proposed: 15-minute reporting below a battery voltage threshold, with 1-minute reporting restored when storms threaten.</a:t>
             </a:r>
           </a:p>
         </p:txBody>
@@ -11283,7 +11295,7 @@
         <p:spPr>
           <a:xfrm>
             <a:off x="914400" y="25694640"/>
-            <a:ext cx="13414248" cy="2834640"/>
+            <a:ext cx="13414248" cy="2990370"/>
           </a:xfrm>
           <a:prstGeom prst="rect">
             <a:avLst/>
@@ -11308,7 +11320,31 @@
               <a:rPr lang="en-US" sz="3467" b="0" dirty="0">
                 <a:latin typeface="Arial"/>
               </a:rPr>
-              <a:t>Testing used a Qoitech Otii Arc power analyzer recording current at up to 4,000 samples per second at the battery’s 3.60 V nominal voltage. The 1-, 15-, and 30-minute schedules were captured for 63, 23, and 16 hours, respectively; the Arc’s UART log matched each current spike to a logged sensor event.</a:t>
+              <a:t>Testing used a Qoitech Otii Arc power </a:t>
+            </a:r>
+            <a:r>
+              <a:rPr lang="en-US" sz="3467" b="0">
+                <a:latin typeface="Arial"/>
+              </a:rPr>
+              <a:t>analyzer recording current at 4,000 samples per second </a:t>
+            </a:r>
+            <a:r>
+              <a:rPr lang="en-US" sz="3467" b="0" dirty="0">
+                <a:latin typeface="Arial"/>
+              </a:rPr>
+              <a:t>at the battery’s 3.60 V nominal voltage. The 1-, 15-, and 30-minute schedules were </a:t>
+            </a:r>
+            <a:r>
+              <a:rPr lang="en-US" sz="3467" b="0">
+                <a:latin typeface="Arial"/>
+              </a:rPr>
+              <a:t>captured for 63, 23, and 16 hours, respectively. The Arc’s UART log matched </a:t>
+            </a:r>
+            <a:r>
+              <a:rPr lang="en-US" sz="3467" b="0" dirty="0">
+                <a:latin typeface="Arial"/>
+              </a:rPr>
+              <a:t>each current spike to a logged sensor event.</a:t>
             </a:r>
           </a:p>
         </p:txBody>
@@ -11380,7 +11416,7 @@
         <p:spPr>
           <a:xfrm>
             <a:off x="15489936" y="11030309"/>
-            <a:ext cx="12920472" cy="1005840"/>
+            <a:ext cx="12920472" cy="1075872"/>
           </a:xfrm>
           <a:prstGeom prst="rect">
             <a:avLst/>
@@ -11405,8 +11441,17 @@
               <a:rPr lang="en-US" sz="3200" b="0" dirty="0">
                 <a:latin typeface="Arial"/>
               </a:rPr>
-              <a:t>Figure 2: Predicted state of charge at 1-, 15-, and 30-minute reporting on a 3,350 mAh cell (datasheet minimum), no solar input</a:t>
+              <a:t>Figure 2: Predicted state of charge at 1-, 15-, and 30-minute </a:t>
             </a:r>
+            <a:r>
+              <a:rPr lang="en-US" sz="3200" b="0">
+                <a:latin typeface="Arial"/>
+              </a:rPr>
+              <a:t>reporting on the Samsung INR18650-35E cell, no solar input</a:t>
+            </a:r>
+            <a:endParaRPr lang="en-US" sz="3200" b="0" dirty="0">
+              <a:latin typeface="Arial"/>
+            </a:endParaRPr>
           </a:p>
         </p:txBody>
       </p:sp>
@@ -11504,7 +11549,19 @@
               <a:rPr lang="en-US" sz="3467" b="0" dirty="0">
                 <a:latin typeface="Arial"/>
               </a:rPr>
-              <a:t>Slowing reporting from 1-minute to 15-minute intervals cut average current draw by 41%, from 2.82 to 1.66 mA; slowing to 30 minutes saved nothing more (1.67 mA, a 0.4% difference within the day-to-day spread). With the battery datasheet (Samsung INR18650-35E lithium-ion, 3,350 mAh minimum), the measured currents project a full charge, with no solar input, lasting 49 days at 1-minute reporting and 84 days at 15- and 30-minute reporting (Figure 2).</a:t>
+              <a:t>Slowing reporting from 1-minute to 15-minute intervals cut average current draw by 41</a:t>
+            </a:r>
+            <a:r>
+              <a:rPr lang="en-US" sz="3467" b="0">
+                <a:latin typeface="Arial"/>
+              </a:rPr>
+              <a:t>%, from 2.82 to 1.66 mA. Slowing to 30 minutes gave no measurable additional saving over 15-minute reporting. With the Samsung INR18650-35E lithium-ion cell (3,350 mAh), the measured currents </a:t>
+            </a:r>
+            <a:r>
+              <a:rPr lang="en-US" sz="3467" b="0" dirty="0">
+                <a:latin typeface="Arial"/>
+              </a:rPr>
+              <a:t>project a full charge, with no solar input, lasting 49 days at 1-minute reporting and 84 days at 15- and 30-minute reporting (Figure 2).</a:t>
             </a:r>
           </a:p>
         </p:txBody>
@@ -11571,8 +11628,8 @@
         </p:nvSpPr>
         <p:spPr>
           <a:xfrm>
-            <a:off x="29584039" y="28032367"/>
-            <a:ext cx="13414248" cy="3931920"/>
+            <a:off x="29584039" y="28346400"/>
+            <a:ext cx="13414248" cy="4170950"/>
           </a:xfrm>
           <a:prstGeom prst="rect">
             <a:avLst/>
@@ -11591,11 +11648,14 @@
               </a:lnSpc>
             </a:pPr>
             <a:r>
-              <a:rPr lang="en-US" sz="3467" b="0" dirty="0">
+              <a:rPr lang="en-US" sz="3467" b="0">
                 <a:latin typeface="Arial"/>
               </a:rPr>
-              <a:t>Proposals: (1) a server-side policy: 1-minute reporting above a battery voltage threshold, 15-minute below; storms or nearby flooding restore 1-minute reporting; (2) raising the 900 s MQTT keepalive toward the Azure IoT Hub ceiling (1,767 s timeout, 1,177 s client keepalive) and measuring energy at longer keepalive intervals; (3) shortening the 250 ms per-record upload pacing.</a:t>
+              <a:t>Proposals: (1) a server-side policy: 1-minute reporting above a battery voltage threshold, 15-minute below, with 1-minute reporting restored when storms or nearby flooding threaten; (2) raising the 900 s MQTT keepalive toward the Azure IoT Hub limit of about 1,177 s and measuring energy at longer keepalive intervals; (3) shortening the 250 ms pause the firmware leaves between queued records during an upload.</a:t>
             </a:r>
+            <a:endParaRPr lang="en-US" sz="3467" b="0" dirty="0">
+              <a:latin typeface="Arial"/>
+            </a:endParaRPr>
           </a:p>
         </p:txBody>
       </p:sp>
@@ -11711,7 +11771,7 @@
           <p:nvPr/>
         </p:nvPicPr>
         <p:blipFill>
-          <a:blip r:embed="rId5"/>
+          <a:blip r:embed="rId4"/>
           <a:stretch>
             <a:fillRect/>
           </a:stretch>
@@ -11880,7 +11940,7 @@
         <p:spPr>
           <a:xfrm>
             <a:off x="29584039" y="22869991"/>
-            <a:ext cx="13414248" cy="4023360"/>
+            <a:ext cx="13414248" cy="4170950"/>
           </a:xfrm>
           <a:prstGeom prst="rect">
             <a:avLst/>
@@ -11902,7 +11962,19 @@
               <a:rPr lang="en-US" sz="3467" b="0" dirty="0">
                 <a:latin typeface="Arial"/>
               </a:rPr>
-              <a:t>Because of the keepalive ping (Figure 4), 15- and 30-minute reporting produce the same four radio wakes per hour and nearly identical radio-active time, so their energy use is equivalent (Figure 5). Radio wakes draw the sensor’s highest instantaneous current (transmit peaks above 100 mA against a 1.26 mA idle floor); the added keepalive wake cancels the saving that halving the upload rate should provide.</a:t>
+              <a:t>Because of the keepalive ping (Figure 4), 15- and 30-minute reporting produce the same four radio wakes per hour and nearly identical radio-active time, so their energy use is equivalent (Figure 5). Radio wakes draw the sensor’s highest instantaneous current (transmit peaks above 100 </a:t>
+            </a:r>
+            <a:r>
+              <a:rPr lang="en-US" sz="3467" b="0">
+                <a:latin typeface="Arial"/>
+              </a:rPr>
+              <a:t>mA against a 1.26 mA idle floor). The added keepalive wake cancels </a:t>
+            </a:r>
+            <a:r>
+              <a:rPr lang="en-US" sz="3467" b="0" dirty="0">
+                <a:latin typeface="Arial"/>
+              </a:rPr>
+              <a:t>the saving that halving the upload rate should provide.</a:t>
             </a:r>
           </a:p>
         </p:txBody>
@@ -11922,7 +11994,7 @@
           <p:nvPr/>
         </p:nvPicPr>
         <p:blipFill>
-          <a:blip r:embed="rId6"/>
+          <a:blip r:embed="rId5"/>
           <a:stretch>
             <a:fillRect/>
           </a:stretch>
@@ -11994,7 +12066,7 @@
           <p:nvPr/>
         </p:nvPicPr>
         <p:blipFill>
-          <a:blip r:embed="rId10"/>
+          <a:blip r:embed="rId6"/>
           <a:stretch>
             <a:fillRect/>
           </a:stretch>
@@ -12018,7 +12090,7 @@
         <p:spPr>
           <a:xfrm>
             <a:off x="7330440" y="29946600"/>
-            <a:ext cx="6998207" cy="1554480"/>
+            <a:ext cx="6998207" cy="2554545"/>
           </a:xfrm>
           <a:prstGeom prst="rect">
             <a:avLst/>
@@ -12035,8 +12107,17 @@
               <a:rPr lang="en-US" sz="3200" b="0" dirty="0">
                 <a:latin typeface="Arial"/>
               </a:rPr>
-              <a:t>Live Otii Arc view during bench testing: current, voltage, and VBUS traces, with the sensor’s time-synced UART log below (current sampled at up to 4,000 samples per second).</a:t>
+              <a:t>Live Otii Arc view during bench testing: current, voltage, and VBUS traces, with the sensor’s time-synced UART log </a:t>
             </a:r>
+            <a:r>
+              <a:rPr lang="en-US" sz="3200" b="0">
+                <a:latin typeface="Arial"/>
+              </a:rPr>
+              <a:t>below (current sampled at 4,000 samples per second).</a:t>
+            </a:r>
+            <a:endParaRPr lang="en-US" sz="3200" b="0" dirty="0">
+              <a:latin typeface="Arial"/>
+            </a:endParaRPr>
           </a:p>
         </p:txBody>
       </p:sp>
@@ -12087,7 +12168,7 @@
           <p:nvPr/>
         </p:nvPicPr>
         <p:blipFill>
-          <a:blip r:embed="rId12"/>
+          <a:blip r:embed="rId7"/>
           <a:stretch>
             <a:fillRect/>
           </a:stretch>
@@ -12111,7 +12192,7 @@
           <p:nvPr/>
         </p:nvPicPr>
         <p:blipFill>
-          <a:blip r:embed="rId9"/>
+          <a:blip r:embed="rId8"/>
           <a:stretch>
             <a:fillRect/>
           </a:stretch>
@@ -12135,7 +12216,7 @@
           <p:nvPr/>
         </p:nvPicPr>
         <p:blipFill>
-          <a:blip r:embed="rId13"/>
+          <a:blip r:embed="rId9"/>
           <a:stretch>
             <a:fillRect/>
           </a:stretch>
@@ -12159,7 +12240,7 @@
           <p:nvPr/>
         </p:nvPicPr>
         <p:blipFill>
-          <a:blip r:embed="rId14"/>
+          <a:blip r:embed="rId10"/>
           <a:stretch>
             <a:fillRect/>
           </a:stretch>

</xml_diff>

<commit_message>
Pre-signoff polish: sensor-exchange wording, keepalive proposal, clarity pass
The crew action is now a sensor exchange everywhere (a crew travels to the
site and swaps the sensor for a charged one), not a battery swap. Future
Work proposal (2) names a defensible configured value: extending the MQTT
keepalive from 15 minutes (900 s) to 19 minutes (1,140 s), just under the
Azure IoT Hub limit, replacing the derived-ceiling phrasing. The paragraph
below Figure 3 now anchors itself to the figures it sits under and drops
steady-state jargon. Recruiter-pass clarity edits: the abstract references
Figure 1, the Figure 3 caption glosses its pulse colors, and Testing names
the serial (UART) log.
</commit_message>
<xml_diff>
--- a/poster/FloodNet_UGSRP_Poster_Final.pptx
+++ b/poster/FloodNet_UGSRP_Poster_Final.pptx
@@ -11166,7 +11166,7 @@
         <p:spPr>
           <a:xfrm>
             <a:off x="914400" y="10591397"/>
-            <a:ext cx="13414248" cy="12710160"/>
+            <a:ext cx="13414248" cy="13121639"/>
           </a:xfrm>
           <a:prstGeom prst="rect">
             <a:avLst/>
@@ -11191,7 +11191,7 @@
               <a:rPr lang="en-US" sz="3467" b="0">
                 <a:latin typeface="Arial"/>
               </a:rPr>
-              <a:t>FloodNet is a street-level flood monitoring network with 450 sensors across New York City’s five boroughs. Each solar-powered unit measures water level every minute with an ultrasonic sensor and reports over cellular at a remotely settable interval (default 1 minute). In winter, shorter days and building shading cut solar harvest below what a shaded sensor consumes. Batteries run down over weeks, sensors shut off and stop reporting, and each one stays dark until a crew spends staff time on a site visit and a battery swap. To measure each reporting rate’s real cost, a sensor’s current draw was recorded with a Qoitech Otii Arc power analyzer at 1-, 15-, and 30-minute intervals (setup below). Slowing reporting from 1 to 15 minutes cut average draw by 41%, from 2.82 to 1.66 mA, stretching a full charge of the Samsung INR18650-35E cell (3,350 mAh) from 49 to 84 days with no solar input (Figure 2). Slowing to 30 minutes saved nothing more: a 900-second MQTT keepalive wakes the modem mid-interval regardless. Fifteen-minute reporting therefore delivers the most live data at the lowest measured power, at the price of reports arriving up to 15 minutes late. A server-side policy is proposed to manage that tradeoff: 15-minute reporting below a battery voltage threshold, with 1-minute reporting restored when a storm is forecast or nearby flooding is detected.</a:t>
+              <a:t>FloodNet is a street-level flood monitoring network with 450 sensors across New York City’s five boroughs. Each solar-powered unit measures water level every minute with an ultrasonic sensor and reports over cellular at a remotely settable interval (default 1 minute). In winter, shorter days and building shading cut solar harvest below what a shaded sensor consumes (Figure 1). Batteries run down over weeks, sensors shut off and stop reporting, and each one stays dark until a crew spends staff time on a site visit, swapping the sensor for a charged one. To measure what each rate really costs, a sensor’s current draw was recorded with a Qoitech Otii Arc power analyzer at 1-, 15-, and 30-minute intervals (setup below). Slowing reporting from 1 to 15 minutes cut average draw by 41%, from 2.82 to 1.66 mA, stretching a full charge of the Samsung INR18650-35E cell (3,350 mAh) from 49 to 84 days with no solar input (Figure 2). Slowing to 30 minutes saved nothing more: a 900-second MQTT keepalive wakes the modem mid-interval regardless. Fifteen-minute reporting thus delivers the most live data at the lowest measured power, at the price of reports arriving up to 15 minutes late. A server-side policy is proposed to manage it: 15-minute reporting below a battery voltage threshold, with 1-minute reporting restored when a storm is forecast or nearby flooding is detected.</a:t>
             </a:r>
             <a:endParaRPr lang="en-US" sz="3467" b="0" dirty="0">
               <a:latin typeface="Arial"/>
@@ -11213,8 +11213,8 @@
         </p:nvSpPr>
         <p:spPr>
           <a:xfrm>
-            <a:off x="914400" y="27980639"/>
-            <a:ext cx="13414248" cy="4709160"/>
+            <a:off x="914400" y="28209239"/>
+            <a:ext cx="13414248" cy="4572000"/>
           </a:xfrm>
           <a:prstGeom prst="rect">
             <a:avLst/>
@@ -11265,8 +11265,8 @@
         </p:nvSpPr>
         <p:spPr>
           <a:xfrm>
-            <a:off x="1161288" y="28099513"/>
-            <a:ext cx="12920472" cy="1005840"/>
+            <a:off x="1161288" y="28328113"/>
+            <a:ext cx="12920472" cy="1161288"/>
           </a:xfrm>
           <a:prstGeom prst="rect">
             <a:avLst/>
@@ -11310,7 +11310,7 @@
         </p:nvSpPr>
         <p:spPr>
           <a:xfrm>
-            <a:off x="914400" y="23545800"/>
+            <a:off x="914400" y="23911561"/>
             <a:ext cx="13414248" cy="1097280"/>
           </a:xfrm>
           <a:prstGeom prst="rect">
@@ -11358,7 +11358,7 @@
         </p:nvSpPr>
         <p:spPr>
           <a:xfrm>
-            <a:off x="914400" y="24688800"/>
+            <a:off x="914400" y="25054561"/>
             <a:ext cx="13414248" cy="2990370"/>
           </a:xfrm>
           <a:prstGeom prst="rect">
@@ -11402,7 +11402,7 @@
               <a:rPr lang="en-US" sz="3467" b="0">
                 <a:latin typeface="Arial"/>
               </a:rPr>
-              <a:t>captured for 63, 23, and 16 hours, respectively. The Arc’s UART log matched </a:t>
+              <a:t>captured for 63, 23, and 16 hours, respectively. The Arc’s serial (UART) log matched </a:t>
             </a:r>
             <a:r>
               <a:rPr lang="en-US" sz="3467" b="0" dirty="0">
@@ -11658,7 +11658,7 @@
               <a:rPr lang="en-US" sz="3467" b="0">
                 <a:latin typeface="Arial"/>
               </a:rPr>
-              <a:t>Proposals: (1) a server-side policy: 1-minute reporting above a battery voltage threshold, 15-minute below, with 1-minute reporting restored when storms or nearby flooding threaten; (2) raising the 900 s MQTT keepalive toward the Azure IoT Hub limit of about 1,177 s and measuring energy at longer keepalive intervals; (3) shortening the 250 ms pause the firmware leaves between queued records during an upload.</a:t>
+              <a:t>Proposals: (1) a server-side policy: 1-minute reporting above a battery voltage threshold, 15-minute below, with 1-minute reporting restored when storms or nearby flooding threaten; (2) extending the MQTT keepalive from 15 minutes (900 s) to 19 minutes (1,140 s), just under the Azure IoT Hub limit, and measuring energy at the longer setting; (3) shortening the 250 ms pause the firmware leaves between queued records during an upload.</a:t>
             </a:r>
             <a:endParaRPr lang="en-US" sz="3467" b="0" dirty="0">
               <a:latin typeface="Arial"/>
@@ -11784,7 +11784,7 @@
         <p:spPr>
           <a:xfrm>
             <a:off x="15489937" y="19110961"/>
-            <a:ext cx="12920472" cy="514500"/>
+            <a:ext cx="12920472" cy="1051560"/>
           </a:xfrm>
           <a:prstGeom prst="rect">
             <a:avLst/>
@@ -11809,14 +11809,11 @@
               <a:rPr lang="en-US" sz="3200" b="0">
                 <a:latin typeface="Arial"/>
               </a:rPr>
-              <a:t>Figure 3: Radio duty cycle </a:t>
+              <a:t>Figure 3: Radio duty cycle over one hour at each reporting rate (dark pulses are uploads, orange are keepalive pings)</a:t>
             </a:r>
-            <a:r>
-              <a:rPr lang="en-US" sz="3200" b="0" dirty="0">
-                <a:latin typeface="Arial"/>
-              </a:rPr>
-              <a:t>over one hour at each reporting rate</a:t>
-            </a:r>
+            <a:endParaRPr lang="en-US" sz="3200" b="0" dirty="0">
+              <a:latin typeface="Arial"/>
+            </a:endParaRPr>
           </a:p>
         </p:txBody>
       </p:sp>
@@ -12088,8 +12085,8 @@
         </p:nvSpPr>
         <p:spPr>
           <a:xfrm>
-            <a:off x="15243048" y="27066239"/>
-            <a:ext cx="13414248" cy="2743200"/>
+            <a:off x="15243048" y="27066238"/>
+            <a:ext cx="13414248" cy="3291840"/>
           </a:xfrm>
           <a:prstGeom prst="rect">
             <a:avLst/>
@@ -12111,7 +12108,7 @@
               <a:rPr lang="en-US" sz="3467" b="0">
                 <a:latin typeface="Arial"/>
               </a:rPr>
-              <a:t>The captures are long by design: cellular network activity varies from cycle to cycle, so each schedule ran long enough to collect many complete reporting cycles, and the steady-state means average complete hours only, with the first boot hour excluded.</a:t>
+              <a:t>The numbers behind Figures 2 and 3 come from deliberately long recordings: cellular network activity varies from cycle to cycle, so each schedule was recorded long enough to collect many complete reporting cycles, and the average currents are computed over complete hours only, with the first boot hour excluded.</a:t>
             </a:r>
             <a:endParaRPr lang="en-US" sz="3467" b="0" dirty="0">
               <a:latin typeface="Arial"/>
@@ -12186,8 +12183,8 @@
         </p:blipFill>
         <p:spPr>
           <a:xfrm>
-            <a:off x="2139696" y="29215079"/>
-            <a:ext cx="10972800" cy="3322015"/>
+            <a:off x="2318004" y="29489400"/>
+            <a:ext cx="10607040" cy="3211373"/>
           </a:xfrm>
           <a:prstGeom prst="rect">
             <a:avLst/>

</xml_diff>

<commit_message>
Pre-signoff polish, items 5-11: field-visit motivation, energy framing
The abstract now motivates the problem with the field-visit reality (a
two-person crew, a ladder and a charged replacement, a far-site swap taking
the better part of a day in a citywide network), drops its Figure 1
citation, states the method as measuring how much energy each reporting
interval consumes on a FloodNet sensor, and standardizes on "reporting
interval" across the poster. Figure 3's caption and the paragraph below it
now read as radio-on time that directly means energy, and a new results
paragraph states the 63-, 23-, and 16-hour capture lengths with the
plain-language stability reason. Column 2 rebalanced; the long abstract
mirrors the crew, hardware, and durations wording.
</commit_message>
<xml_diff>
--- a/poster/FloodNet_UGSRP_Poster_Final.pptx
+++ b/poster/FloodNet_UGSRP_Poster_Final.pptx
@@ -10712,8 +10712,8 @@
         </p:nvSpPr>
         <p:spPr>
           <a:xfrm>
-            <a:off x="15243048" y="18836639"/>
-            <a:ext cx="13414248" cy="6858000"/>
+            <a:off x="15243048" y="18150839"/>
+            <a:ext cx="13414248" cy="7589520"/>
           </a:xfrm>
           <a:prstGeom prst="rect">
             <a:avLst/>
@@ -11165,8 +11165,8 @@
         </p:nvSpPr>
         <p:spPr>
           <a:xfrm>
-            <a:off x="914400" y="10591397"/>
-            <a:ext cx="13414248" cy="13121639"/>
+            <a:off x="914400" y="10591398"/>
+            <a:ext cx="13414248" cy="13330509"/>
           </a:xfrm>
           <a:prstGeom prst="rect">
             <a:avLst/>
@@ -11191,7 +11191,7 @@
               <a:rPr lang="en-US" sz="3467" b="0">
                 <a:latin typeface="Arial"/>
               </a:rPr>
-              <a:t>FloodNet is a street-level flood monitoring network with 450 sensors across New York City’s five boroughs. Each solar-powered unit measures water level every minute with an ultrasonic sensor and reports over cellular at a remotely settable interval (default 1 minute). In winter, shorter days and building shading cut solar harvest below what a shaded sensor consumes (Figure 1). Batteries run down over weeks, sensors shut off and stop reporting, and each one stays dark until a crew spends staff time on a site visit, swapping the sensor for a charged one. To measure what each rate really costs, a sensor’s current draw was recorded with a Qoitech Otii Arc power analyzer at 1-, 15-, and 30-minute intervals (setup below). Slowing reporting from 1 to 15 minutes cut average draw by 41%, from 2.82 to 1.66 mA, stretching a full charge of the Samsung INR18650-35E cell (3,350 mAh) from 49 to 84 days with no solar input (Figure 2). Slowing to 30 minutes saved nothing more: a 900-second MQTT keepalive wakes the modem mid-interval regardless. Fifteen-minute reporting thus delivers the most live data at the lowest measured power, at the price of reports arriving up to 15 minutes late. A server-side policy is proposed to manage it: 15-minute reporting below a battery voltage threshold, with 1-minute reporting restored when a storm is forecast or nearby flooding is detected.</a:t>
+              <a:t>FloodNet is a street-level flood monitoring network with 450 sensors across New York City’s five boroughs. Each solar-powered unit measures water level every minute by ultrasonic sensor and reports over cellular at a remotely settable reporting interval (default 1 minute). In winter, short days and building shading cut solar harvest below what a shaded sensor consumes. Batteries run down over weeks and sensors shut off and stop reporting. A dead sensor needs a two-person crew to drive out with a ladder and a charged replacement, and a far-site swap in this citywide network can take the better part of a day. To measure how much energy each reporting interval actually consumes, a FloodNet sensor’s current draw was recorded with a Qoitech Otii Arc power analyzer at 1-, 15-, and 30-minute intervals (setup below). Slowing reporting from 1 to 15 minutes cut average draw by 41%, from 2.82 to 1.66 mA, stretching a full charge of its Samsung INR18650-35E cell (3,350 mAh) from 49 to 84 days with no solar input (Figure 2). Slowing to 30 minutes saved nothing more: a 900-second MQTT keepalive wakes the radio mid-interval anyway. Fifteen-minute reporting delivers the most live data at the lowest measured power, at the price of reports up to 15 minutes late. A server-side policy is proposed: 15-minute reporting below a battery voltage threshold, with 1-minute reporting restored when storms or nearby flooding threaten.</a:t>
             </a:r>
             <a:endParaRPr lang="en-US" sz="3467" b="0" dirty="0">
               <a:latin typeface="Arial"/>
@@ -11213,8 +11213,8 @@
         </p:nvSpPr>
         <p:spPr>
           <a:xfrm>
-            <a:off x="914400" y="28209239"/>
-            <a:ext cx="13414248" cy="4572000"/>
+            <a:off x="914400" y="28529279"/>
+            <a:ext cx="13414248" cy="4251960"/>
           </a:xfrm>
           <a:prstGeom prst="rect">
             <a:avLst/>
@@ -11265,7 +11265,7 @@
         </p:nvSpPr>
         <p:spPr>
           <a:xfrm>
-            <a:off x="1161288" y="28328113"/>
+            <a:off x="1161288" y="28648152"/>
             <a:ext cx="12920472" cy="1161288"/>
           </a:xfrm>
           <a:prstGeom prst="rect">
@@ -11310,7 +11310,7 @@
         </p:nvSpPr>
         <p:spPr>
           <a:xfrm>
-            <a:off x="914400" y="23911561"/>
+            <a:off x="914400" y="24277320"/>
             <a:ext cx="13414248" cy="1097280"/>
           </a:xfrm>
           <a:prstGeom prst="rect">
@@ -11358,8 +11358,8 @@
         </p:nvSpPr>
         <p:spPr>
           <a:xfrm>
-            <a:off x="914400" y="25054561"/>
-            <a:ext cx="13414248" cy="2990370"/>
+            <a:off x="914400" y="25420320"/>
+            <a:ext cx="13414248" cy="2990088"/>
           </a:xfrm>
           <a:prstGeom prst="rect">
             <a:avLst/>
@@ -11396,13 +11396,13 @@
               <a:rPr lang="en-US" sz="3467" b="0" dirty="0">
                 <a:latin typeface="Arial"/>
               </a:rPr>
-              <a:t>at the battery’s 3.60 V nominal voltage. The 1-, 15-, and 30-minute schedules were </a:t>
+              <a:t>at the battery’s 3.60 V nominal voltage</a:t>
             </a:r>
             <a:r>
               <a:rPr lang="en-US" sz="3467" b="0">
                 <a:latin typeface="Arial"/>
               </a:rPr>
-              <a:t>captured for 63, 23, and 16 hours, respectively. The Arc’s serial (UART) log matched </a:t>
+              <a:t>. The 1-, 15-, and 30-minute reporting intervals were captured for 63, 23, and 16 hours, respectively. The Arc’s serial (UART) log matched </a:t>
             </a:r>
             <a:r>
               <a:rPr lang="en-US" sz="3467" b="0" dirty="0">
@@ -11700,16 +11700,22 @@
               </a:lnSpc>
             </a:pPr>
             <a:r>
+              <a:rPr lang="en-US" sz="3467" b="0">
+                <a:latin typeface="Arial"/>
+              </a:rPr>
+              <a:t>The radio wakes only once per reporting interval </a:t>
+            </a:r>
+            <a:r>
               <a:rPr lang="en-US" sz="3467" b="0" dirty="0">
                 <a:latin typeface="Arial"/>
               </a:rPr>
-              <a:t>The radio wakes only once per interval to send its stored readings, but the MQTT connection times out after 900 seconds without traffic, so the 30-minute schedule adds a mid-interval keepalive </a:t>
+              <a:t>to send its stored readings, but the MQTT connection times out after 900 seconds without traffic</a:t>
             </a:r>
             <a:r>
               <a:rPr lang="en-US" sz="3467" b="0">
                 <a:latin typeface="Arial"/>
               </a:rPr>
-              <a:t>ping (orange pulses, Figure 3).</a:t>
+              <a:t>, so the 30-minute reporting interval adds a mid-interval keepalive ping (orange pulses, Figure 3).</a:t>
             </a:r>
             <a:endParaRPr lang="en-US" sz="3467" b="0" dirty="0">
               <a:latin typeface="Arial"/>
@@ -11783,8 +11789,8 @@
         </p:nvSpPr>
         <p:spPr>
           <a:xfrm>
-            <a:off x="15489937" y="19110961"/>
-            <a:ext cx="12920472" cy="1051560"/>
+            <a:off x="15489937" y="18333720"/>
+            <a:ext cx="12920472" cy="1691640"/>
           </a:xfrm>
           <a:prstGeom prst="rect">
             <a:avLst/>
@@ -11809,7 +11815,7 @@
               <a:rPr lang="en-US" sz="3200" b="0">
                 <a:latin typeface="Arial"/>
               </a:rPr>
-              <a:t>Figure 3: Radio duty cycle over one hour at each reporting rate (dark pulses are uploads, orange are keepalive pings)</a:t>
+              <a:t>Figure 3: Radio duty cycle at each reporting interval: the share of each hour the radio is on (dark pulses are uploads, orange are keepalive pings)</a:t>
             </a:r>
             <a:endParaRPr lang="en-US" sz="3200" b="0" dirty="0">
               <a:latin typeface="Arial"/>
@@ -12063,7 +12069,7 @@
         </p:blipFill>
         <p:spPr>
           <a:xfrm>
-            <a:off x="15416785" y="20208239"/>
+            <a:off x="15416785" y="20071080"/>
             <a:ext cx="13075921" cy="5349240"/>
           </a:xfrm>
           <a:prstGeom prst="rect">
@@ -12085,8 +12091,8 @@
         </p:nvSpPr>
         <p:spPr>
           <a:xfrm>
-            <a:off x="15243048" y="27066238"/>
-            <a:ext cx="13414248" cy="3291840"/>
+            <a:off x="15243048" y="26106121"/>
+            <a:ext cx="13414248" cy="2468880"/>
           </a:xfrm>
           <a:prstGeom prst="rect">
             <a:avLst/>
@@ -12108,7 +12114,7 @@
               <a:rPr lang="en-US" sz="3467" b="0">
                 <a:latin typeface="Arial"/>
               </a:rPr>
-              <a:t>The numbers behind Figures 2 and 3 come from deliberately long recordings: cellular network activity varies from cycle to cycle, so each schedule was recorded long enough to collect many complete reporting cycles, and the average currents are computed over complete hours only, with the first boot hour excluded.</a:t>
+              <a:t>Figure 3 shows the fraction of each hour the radio is on. Radio-on time is what consumes the battery, and it is nearly identical at 15- and 30-minute reporting intervals, which is why 30-minute reporting saves nothing more.</a:t>
             </a:r>
             <a:endParaRPr lang="en-US" sz="3467" b="0" dirty="0">
               <a:latin typeface="Arial"/>
@@ -12183,14 +12189,59 @@
         </p:blipFill>
         <p:spPr>
           <a:xfrm>
-            <a:off x="2318004" y="29489400"/>
-            <a:ext cx="10607040" cy="3211373"/>
+            <a:off x="2912364" y="29827727"/>
+            <a:ext cx="9418320" cy="2851099"/>
           </a:xfrm>
           <a:prstGeom prst="rect">
             <a:avLst/>
           </a:prstGeom>
         </p:spPr>
       </p:pic>
+      <p:sp>
+        <p:nvSpPr>
+          <p:cNvPr id="6" name="DurationsBlock">
+            <a:extLst>
+              <a:ext uri="{FF2B5EF4-FFF2-40B4-BE49-F238E27FC236}">
+                <a16:creationId xmlns:a16="http://schemas.microsoft.com/office/drawing/2014/main" id="{22E3CF95-8697-6BB2-DFB0-3F44755482CF}"/>
+              </a:ext>
+            </a:extLst>
+          </p:cNvPr>
+          <p:cNvSpPr txBox="1"/>
+          <p:nvPr/>
+        </p:nvSpPr>
+        <p:spPr>
+          <a:xfrm>
+            <a:off x="15243048" y="29032200"/>
+            <a:ext cx="13414248" cy="3657600"/>
+          </a:xfrm>
+          <a:prstGeom prst="rect">
+            <a:avLst/>
+          </a:prstGeom>
+          <a:noFill/>
+        </p:spPr>
+        <p:txBody>
+          <a:bodyPr wrap="square" lIns="0" tIns="0" rIns="0" bIns="0">
+            <a:spAutoFit/>
+          </a:bodyPr>
+          <a:lstStyle/>
+          <a:p>
+            <a:pPr>
+              <a:lnSpc>
+                <a:spcPct val="113000"/>
+              </a:lnSpc>
+            </a:pPr>
+            <a:r>
+              <a:rPr lang="en-US" sz="3467" b="0">
+                <a:latin typeface="Arial"/>
+              </a:rPr>
+              <a:t>The averages behind Figures 2 and 3 come from deliberately long captures: 63, 23, and 16 hours at the three reporting intervals. Averaging over dozens of reporting cycles and many hours of cellular network variability makes the averages stable rather than dependent on any single stretch of conditions, computed over complete hours only with the first boot hour excluded.</a:t>
+            </a:r>
+            <a:endParaRPr lang="en-US" sz="3467" b="0" dirty="0">
+              <a:latin typeface="Arial"/>
+            </a:endParaRPr>
+          </a:p>
+        </p:txBody>
+      </p:sp>
     </p:spTree>
     <p:extLst>
       <p:ext uri="{BB962C8B-B14F-4D97-AF65-F5344CB8AC3E}">

</xml_diff>

<commit_message>
Revert field-visit detail; scope the duty-cycle energy claim
The motivation wording returns to the round-9 phrasing with only the
charged-sensor correction kept (a crew travels out and swaps the sensor for
a charged one); the two-person, ladder, and day-long details are out. The
paragraph below Figure 3 now scopes the energy claim to what the evidence
supports: the radio consumes the majority of the battery at the default
1-minute interval, and radio-on time is the part of the energy budget the
reporting interval controls. The long abstract also aligns "slowing the
reporting rate" to "slowing the reporting interval".
</commit_message>
<xml_diff>
--- a/poster/FloodNet_UGSRP_Poster_Final.pptx
+++ b/poster/FloodNet_UGSRP_Poster_Final.pptx
@@ -11166,7 +11166,7 @@
         <p:spPr>
           <a:xfrm>
             <a:off x="914400" y="10591398"/>
-            <a:ext cx="13414248" cy="13330509"/>
+            <a:ext cx="13414248" cy="12722265"/>
           </a:xfrm>
           <a:prstGeom prst="rect">
             <a:avLst/>
@@ -11191,7 +11191,7 @@
               <a:rPr lang="en-US" sz="3467" b="0">
                 <a:latin typeface="Arial"/>
               </a:rPr>
-              <a:t>FloodNet is a street-level flood monitoring network with 450 sensors across New York City’s five boroughs. Each solar-powered unit measures water level every minute by ultrasonic sensor and reports over cellular at a remotely settable reporting interval (default 1 minute). In winter, short days and building shading cut solar harvest below what a shaded sensor consumes. Batteries run down over weeks and sensors shut off and stop reporting. A dead sensor needs a two-person crew to drive out with a ladder and a charged replacement, and a far-site swap in this citywide network can take the better part of a day. To measure how much energy each reporting interval actually consumes, a FloodNet sensor’s current draw was recorded with a Qoitech Otii Arc power analyzer at 1-, 15-, and 30-minute intervals (setup below). Slowing reporting from 1 to 15 minutes cut average draw by 41%, from 2.82 to 1.66 mA, stretching a full charge of its Samsung INR18650-35E cell (3,350 mAh) from 49 to 84 days with no solar input (Figure 2). Slowing to 30 minutes saved nothing more: a 900-second MQTT keepalive wakes the radio mid-interval anyway. Fifteen-minute reporting delivers the most live data at the lowest measured power, at the price of reports up to 15 minutes late. A server-side policy is proposed: 15-minute reporting below a battery voltage threshold, with 1-minute reporting restored when storms or nearby flooding threaten.</a:t>
+              <a:t>FloodNet is a street-level flood monitoring network with 450 sensors across New York City’s five boroughs. Each solar-powered unit measures water level every minute by ultrasonic sensor and reports over cellular at a remotely settable reporting interval (default 1 minute). In winter, short days and building shading cut solar harvest below what a shaded sensor consumes. Batteries run down over weeks, sensors shut off and stop reporting, and each one stays dark until a crew spends staff time on a site visit, swapping the sensor for a charged one. To measure how much energy each reporting interval actually consumes, a FloodNet sensor’s current draw was recorded with a Qoitech Otii Arc power analyzer at 1-, 15-, and 30-minute intervals (setup below). Slowing reporting from 1 to 15 minutes cut average draw by 41%, from 2.82 to 1.66 mA, stretching a full charge of its Samsung INR18650-35E cell (3,350 mAh) from 49 to 84 days with no solar input (Figure 2). Slowing to 30 minutes saved nothing more: a 900-second MQTT keepalive wakes the radio mid-interval anyway. Fifteen-minute reporting delivers the most live data at the lowest measured power, at the price of reports up to 15 minutes late. A server-side policy is proposed: 15-minute reporting below a battery voltage threshold, with 1-minute reporting restored when storms or nearby flooding threaten.</a:t>
             </a:r>
             <a:endParaRPr lang="en-US" sz="3467" b="0" dirty="0">
               <a:latin typeface="Arial"/>
@@ -12091,8 +12091,8 @@
         </p:nvSpPr>
         <p:spPr>
           <a:xfrm>
-            <a:off x="15243048" y="26106121"/>
-            <a:ext cx="13414248" cy="2468880"/>
+            <a:off x="15243048" y="26014679"/>
+            <a:ext cx="13414248" cy="3017520"/>
           </a:xfrm>
           <a:prstGeom prst="rect">
             <a:avLst/>
@@ -12114,7 +12114,7 @@
               <a:rPr lang="en-US" sz="3467" b="0">
                 <a:latin typeface="Arial"/>
               </a:rPr>
-              <a:t>Figure 3 shows the fraction of each hour the radio is on. Radio-on time is what consumes the battery, and it is nearly identical at 15- and 30-minute reporting intervals, which is why 30-minute reporting saves nothing more.</a:t>
+              <a:t>Figure 3 shows the share of each hour the radio is on. At the default 1-minute interval the radio consumes the majority of the battery, and radio-on time is the part of the energy budget the reporting interval controls. That on-time is nearly identical at 15 and 30 minutes, which is why slowing past 15 minutes saves nothing measurable.</a:t>
             </a:r>
             <a:endParaRPr lang="en-US" sz="3467" b="0" dirty="0">
               <a:latin typeface="Arial"/>
@@ -12211,8 +12211,8 @@
         </p:nvSpPr>
         <p:spPr>
           <a:xfrm>
-            <a:off x="15243048" y="29032200"/>
-            <a:ext cx="13414248" cy="3657600"/>
+            <a:off x="15243048" y="29215079"/>
+            <a:ext cx="13414248" cy="3566160"/>
           </a:xfrm>
           <a:prstGeom prst="rect">
             <a:avLst/>

</xml_diff>